<commit_message>
Fix repository identity and links for aj-enns Pages
Update portal branding, docs, demo repository guards, and generated slide links to the fork. Add browser coverage for the displayed repository identity.

Co-authored-by: Copilot App <223556219+Copilot@users.noreply.github.com>

Copilot-Session: 0bdefde5-1bd2-4805-8358-5b2a8f5838ff
</commit_message>
<xml_diff>
--- a/artifacts/slides/agentic-workflows.pptx
+++ b/artifacts/slides/agentic-workflows.pptx
@@ -506,7 +506,7 @@
               <a:t>GitHub Agentic Workflows: what it does, where value comes from, and the bounded control story.,Exact lifecycle: technical-preview. The official announcement names a technical preview. Recheck current lifecycle before adoption.,Verification date: 2026-10-14. Evidence older than 30 days requires re-review.,This is independent enablement for a controlled pilot, not production certification or customer-specific approval.,Cost detail: Copilot-engine inference is governed by its billing entity; other engines have their own provider charges. Private-repository Actions usage can consume included minutes and incur overage. The deterministic daily scan does not call an AI model.,Explicit assumptions:
 GitHub Actions is allowed for this repository.
 AI-engine authentication and budget are administrator-owned.
-No claim that a scheduled workflow is free or that a PAT supplies unlimited usage.,Complete assessment: https://github.com/hammadorg93/copilot-runway/blob/main/features/agentic-workflows/assessment.md,Presenter runbook: https://github.com/hammadorg93/copilot-runway/blob/main/demos/agentic-workflows/README.md,Kit validation: kit-tested. Live feature validation: not-run.,Remote cleanup: Disable the opt-in and cancel only exact demo runs; draft PRs and Actions logs are not removed by a local reset.,Primary sources:
+No claim that a scheduled workflow is free or that a PAT supplies unlimited usage.,Complete assessment: https://github.com/aj-enns/copilot-runway/blob/main/features/agentic-workflows/assessment.md,Presenter runbook: https://github.com/aj-enns/copilot-runway/blob/main/demos/agentic-workflows/README.md,Kit validation: kit-tested. Live feature validation: not-run.,Remote cleanup: Disable the opt-in and cancel only exact demo runs; draft PRs and Actions logs are not removed by a local reset.,Primary sources:
 GitHub Agentic Workflows technical preview announcement: https://github.blog/changelog/2026-02-13-github-agentic-workflows-are-now-in-technical-preview/
 GitHub Agentic Workflows quick start and authentication: https://github.github.io/gh-aw/setup/quick-start/
 Usage-based billing for organizations and enterprises: https://docs.github.com/en/copilot/concepts/billing-and-usage/organizations-and-enterprises/billing
@@ -602,7 +602,7 @@
               <a:t>GitHub Agentic Workflows: pilot decision, evidence gaps, cost assumptions, and how to start the repeatable demo kit.,Exact lifecycle: technical-preview. The official announcement names a technical preview. Recheck current lifecycle before adoption.,Verification date: 2026-10-14. Evidence older than 30 days requires re-review.,This is independent enablement for a controlled pilot, not production certification or customer-specific approval.,Cost detail: Copilot-engine inference is governed by its billing entity; other engines have their own provider charges. Private-repository Actions usage can consume included minutes and incur overage. The deterministic daily scan does not call an AI model.,Explicit assumptions:
 GitHub Actions is allowed for this repository.
 AI-engine authentication and budget are administrator-owned.
-No claim that a scheduled workflow is free or that a PAT supplies unlimited usage.,Complete assessment: https://github.com/hammadorg93/copilot-runway/blob/main/features/agentic-workflows/assessment.md,Presenter runbook: https://github.com/hammadorg93/copilot-runway/blob/main/demos/agentic-workflows/README.md,Kit validation: kit-tested. Live feature validation: not-run.,Remote cleanup: Disable the opt-in and cancel only exact demo runs; draft PRs and Actions logs are not removed by a local reset.,Primary sources:
+No claim that a scheduled workflow is free or that a PAT supplies unlimited usage.,Complete assessment: https://github.com/aj-enns/copilot-runway/blob/main/features/agentic-workflows/assessment.md,Presenter runbook: https://github.com/aj-enns/copilot-runway/blob/main/demos/agentic-workflows/README.md,Kit validation: kit-tested. Live feature validation: not-run.,Remote cleanup: Disable the opt-in and cancel only exact demo runs; draft PRs and Actions logs are not removed by a local reset.,Primary sources:
 GitHub Agentic Workflows technical preview announcement: https://github.blog/changelog/2026-02-13-github-agentic-workflows-are-now-in-technical-preview/
 GitHub Agentic Workflows quick start and authentication: https://github.github.io/gh-aw/setup/quick-start/
 Usage-based billing for organizations and enterprises: https://docs.github.com/en/copilot/concepts/billing-and-usage/organizations-and-enterprises/billing

</xml_diff>